<commit_message>
Update presentation slides (Sepolia demo, edited locally)
</commit_message>
<xml_diff>
--- a/slides/Task3_slides.pptx
+++ b/slides/Task3_slides.pptx
@@ -325,6 +325,17 @@
               <a:t> now.</a:t>
             </a:r>
           </a:p>
+          <a:p>
+            <a:r>
+              <a:rPr lang="en-US" dirty="0"/>
+              <a:t>SLIDE 1 — Title &amp; team          [0:20]  (cum 0:20)   </a:t>
+            </a:r>
+            <a:r>
+              <a:rPr lang="en-US" dirty="0" err="1"/>
+              <a:t>Yankai</a:t>
+            </a:r>
+            <a:endParaRPr lang="en-US" dirty="0"/>
+          </a:p>
         </p:txBody>
       </p:sp>
       <p:sp>
@@ -436,6 +447,17 @@
               <a:t> receives temperature data. If a reading is outside two to eight degrees, it quarantines the batch by itself, with a cross-contract call. Only this contract can do that — no person can. On the right: the off-chain parts. The oracle service reads the sensors and sends signed data. The store keeps metadata and patient data off-chain. The rule is simple: state goes on-chain; private data stays off-chain; only hashes connect them.</a:t>
             </a:r>
           </a:p>
+          <a:p>
+            <a:r>
+              <a:rPr lang="en-US" dirty="0"/>
+              <a:t>SLIDE 2 — Architecture          [0:40]  (cum 1:00)   </a:t>
+            </a:r>
+            <a:r>
+              <a:rPr lang="en-US" dirty="0" err="1"/>
+              <a:t>Yankai</a:t>
+            </a:r>
+            <a:endParaRPr lang="en-US" dirty="0"/>
+          </a:p>
         </p:txBody>
       </p:sp>
       <p:sp>
@@ -539,6 +561,17 @@
               <a:t> account, and the contract checks every reading. Third, non-repudiation is now real: every write is a signed transaction, so we always know who did what. Fourth, clear scope: the three MUSTs and the SHOULD are fully on-chain; the IoT part is simulated. In production we would move to a consortium chain — the contracts would not change.</a:t>
             </a:r>
           </a:p>
+          <a:p>
+            <a:r>
+              <a:rPr lang="en-US" dirty="0"/>
+              <a:t>SLIDE 3 — Changes after feedback [0:40]  (cum 1:40)   </a:t>
+            </a:r>
+            <a:r>
+              <a:rPr lang="en-US" dirty="0" err="1"/>
+              <a:t>Purui</a:t>
+            </a:r>
+            <a:endParaRPr lang="en-US" dirty="0"/>
+          </a:p>
         </p:txBody>
       </p:sp>
       <p:sp>
@@ -626,6 +659,17 @@
               <a:t>This table maps each requirement to a contract function — you will see all of them in the demo. The first four are fully on-chain. The cold-chain one uses simulated sensors. The NFRs at the bottom each map to a real mechanism, not a promise. Now the demo.</a:t>
             </a:r>
           </a:p>
+          <a:p>
+            <a:r>
+              <a:rPr lang="en-US" dirty="0"/>
+              <a:t>SLIDE 4 — Requirements          [0:20]  (cum 2:00)   </a:t>
+            </a:r>
+            <a:r>
+              <a:rPr lang="en-US" dirty="0" err="1"/>
+              <a:t>Purui</a:t>
+            </a:r>
+            <a:endParaRPr lang="en-US" dirty="0"/>
+          </a:p>
         </p:txBody>
       </p:sp>
       <p:sp>
@@ -729,6 +773,13 @@
               <a:t> — addresses are in addresses.txt. We used six patterns from this course: oracle, access control, state machine, emergency stop, hash anchoring, checks-effects-interactions. Thirty-one unit tests, all passing, covering both good and bad paths. The repo is clean and easy to reproduce.</a:t>
             </a:r>
           </a:p>
+          <a:p>
+            <a:r>
+              <a:rPr lang="fr-FR" dirty="0"/>
+              <a:t>SLIDE 5 — Implementation        [0:30]  (cum 2:30)   Fei</a:t>
+            </a:r>
+            <a:endParaRPr lang="en-US" dirty="0"/>
+          </a:p>
         </p:txBody>
       </p:sp>
       <p:sp>
@@ -822,6 +873,12 @@
             <a:r>
               <a:rPr lang="en-US" dirty="0"/>
               <a:t>.</a:t>
+            </a:r>
+          </a:p>
+          <a:p>
+            <a:r>
+              <a:rPr lang="en-US" dirty="0"/>
+              <a:t>SLIDE 6 — Demo plan             [0:15]  (cum 2:45)   Fei</a:t>
             </a:r>
           </a:p>
         </p:txBody>

</xml_diff>